<commit_message>
Fix visual defects: audience-rings figure and slide layout collisions
The Ch2 audience figure laid long ring labels across the curved color
bands, making text blend into the graphic — redesigned with the rings
on the left and a color-chip legend beside them. The Ch7 "pivot" slide
in the deployed deck had a stale duplicate title overlapping content;
all 17 decks are rebuilt from current source to flush stale builds.
takeaways_slide now adapts row spacing and font size to the item
count so long takeaway lists can never collide with the practice-
reminder card (Ch3's 7-item recap did). A programmatic overlap scan
across every slide of all 17 decks now reports zero text collisions,
and the Ch2 guide and compiled textbook are rebuilt with the fixed
figure (pagination unchanged: 413 pages).
</commit_message>
<xml_diff>
--- a/slides/ch03-organizing-and-drafting.pptx
+++ b/slides/ch03-organizing-and-drafting.pptx
@@ -14270,7 +14270,7 @@
         <p:spPr>
           <a:xfrm>
             <a:off x="1325880" y="1554480"/>
-            <a:ext cx="10332720" cy="640080"/>
+            <a:ext cx="10332720" cy="555171"/>
           </a:xfrm>
           <a:prstGeom prst="rect">
             <a:avLst/>
@@ -14289,7 +14289,7 @@
               </a:spcAft>
             </a:pPr>
             <a:r>
-              <a:rPr sz="1550" b="0" i="0">
+              <a:rPr sz="1350" b="0" i="0">
                 <a:solidFill>
                   <a:srgbClr val="212A26"/>
                 </a:solidFill>
@@ -14308,7 +14308,7 @@
         </p:nvSpPr>
         <p:spPr>
           <a:xfrm>
-            <a:off x="640080" y="2212848"/>
+            <a:off x="640080" y="2127939"/>
             <a:ext cx="420624" cy="420624"/>
           </a:xfrm>
           <a:prstGeom prst="ellipse">
@@ -14361,8 +14361,8 @@
         </p:nvSpPr>
         <p:spPr>
           <a:xfrm>
-            <a:off x="1325880" y="2194560"/>
-            <a:ext cx="10332720" cy="640080"/>
+            <a:off x="1325880" y="2109651"/>
+            <a:ext cx="10332720" cy="555171"/>
           </a:xfrm>
           <a:prstGeom prst="rect">
             <a:avLst/>
@@ -14381,7 +14381,7 @@
               </a:spcAft>
             </a:pPr>
             <a:r>
-              <a:rPr sz="1550" b="0" i="0">
+              <a:rPr sz="1350" b="0" i="0">
                 <a:solidFill>
                   <a:srgbClr val="212A26"/>
                 </a:solidFill>
@@ -14400,7 +14400,7 @@
         </p:nvSpPr>
         <p:spPr>
           <a:xfrm>
-            <a:off x="640080" y="2852928"/>
+            <a:off x="640080" y="2683110"/>
             <a:ext cx="420624" cy="420624"/>
           </a:xfrm>
           <a:prstGeom prst="ellipse">
@@ -14453,8 +14453,8 @@
         </p:nvSpPr>
         <p:spPr>
           <a:xfrm>
-            <a:off x="1325880" y="2834640"/>
-            <a:ext cx="10332720" cy="640080"/>
+            <a:off x="1325880" y="2664822"/>
+            <a:ext cx="10332720" cy="555171"/>
           </a:xfrm>
           <a:prstGeom prst="rect">
             <a:avLst/>
@@ -14473,7 +14473,7 @@
               </a:spcAft>
             </a:pPr>
             <a:r>
-              <a:rPr sz="1550" b="0" i="0">
+              <a:rPr sz="1350" b="0" i="0">
                 <a:solidFill>
                   <a:srgbClr val="212A26"/>
                 </a:solidFill>
@@ -14492,7 +14492,7 @@
         </p:nvSpPr>
         <p:spPr>
           <a:xfrm>
-            <a:off x="640080" y="3493008"/>
+            <a:off x="640080" y="3238281"/>
             <a:ext cx="420624" cy="420624"/>
           </a:xfrm>
           <a:prstGeom prst="ellipse">
@@ -14545,8 +14545,8 @@
         </p:nvSpPr>
         <p:spPr>
           <a:xfrm>
-            <a:off x="1325880" y="3474720"/>
-            <a:ext cx="10332720" cy="640080"/>
+            <a:off x="1325880" y="3219993"/>
+            <a:ext cx="10332720" cy="555171"/>
           </a:xfrm>
           <a:prstGeom prst="rect">
             <a:avLst/>
@@ -14565,7 +14565,7 @@
               </a:spcAft>
             </a:pPr>
             <a:r>
-              <a:rPr sz="1550" b="0" i="0">
+              <a:rPr sz="1350" b="0" i="0">
                 <a:solidFill>
                   <a:srgbClr val="212A26"/>
                 </a:solidFill>
@@ -14584,7 +14584,7 @@
         </p:nvSpPr>
         <p:spPr>
           <a:xfrm>
-            <a:off x="640080" y="4133088"/>
+            <a:off x="640080" y="3793452"/>
             <a:ext cx="420624" cy="420624"/>
           </a:xfrm>
           <a:prstGeom prst="ellipse">
@@ -14637,8 +14637,8 @@
         </p:nvSpPr>
         <p:spPr>
           <a:xfrm>
-            <a:off x="1325880" y="4114800"/>
-            <a:ext cx="10332720" cy="640080"/>
+            <a:off x="1325880" y="3775164"/>
+            <a:ext cx="10332720" cy="555171"/>
           </a:xfrm>
           <a:prstGeom prst="rect">
             <a:avLst/>
@@ -14657,7 +14657,7 @@
               </a:spcAft>
             </a:pPr>
             <a:r>
-              <a:rPr sz="1550" b="0" i="0">
+              <a:rPr sz="1350" b="0" i="0">
                 <a:solidFill>
                   <a:srgbClr val="212A26"/>
                 </a:solidFill>
@@ -14676,7 +14676,7 @@
         </p:nvSpPr>
         <p:spPr>
           <a:xfrm>
-            <a:off x="640080" y="4773168"/>
+            <a:off x="640080" y="4348623"/>
             <a:ext cx="420624" cy="420624"/>
           </a:xfrm>
           <a:prstGeom prst="ellipse">
@@ -14729,8 +14729,8 @@
         </p:nvSpPr>
         <p:spPr>
           <a:xfrm>
-            <a:off x="1325880" y="4754880"/>
-            <a:ext cx="10332720" cy="640080"/>
+            <a:off x="1325880" y="4330335"/>
+            <a:ext cx="10332720" cy="555171"/>
           </a:xfrm>
           <a:prstGeom prst="rect">
             <a:avLst/>
@@ -14749,7 +14749,7 @@
               </a:spcAft>
             </a:pPr>
             <a:r>
-              <a:rPr sz="1550" b="0" i="0">
+              <a:rPr sz="1350" b="0" i="0">
                 <a:solidFill>
                   <a:srgbClr val="212A26"/>
                 </a:solidFill>
@@ -14768,7 +14768,7 @@
         </p:nvSpPr>
         <p:spPr>
           <a:xfrm>
-            <a:off x="640080" y="5413248"/>
+            <a:off x="640080" y="4903794"/>
             <a:ext cx="420624" cy="420624"/>
           </a:xfrm>
           <a:prstGeom prst="ellipse">
@@ -14821,8 +14821,8 @@
         </p:nvSpPr>
         <p:spPr>
           <a:xfrm>
-            <a:off x="1325880" y="5394960"/>
-            <a:ext cx="10332720" cy="640080"/>
+            <a:off x="1325880" y="4885506"/>
+            <a:ext cx="10332720" cy="555171"/>
           </a:xfrm>
           <a:prstGeom prst="rect">
             <a:avLst/>
@@ -14841,7 +14841,7 @@
               </a:spcAft>
             </a:pPr>
             <a:r>
-              <a:rPr sz="1550" b="0" i="0">
+              <a:rPr sz="1350" b="0" i="0">
                 <a:solidFill>
                   <a:srgbClr val="212A26"/>
                 </a:solidFill>
@@ -14860,7 +14860,7 @@
         </p:nvSpPr>
         <p:spPr>
           <a:xfrm>
-            <a:off x="548640" y="5623560"/>
+            <a:off x="548640" y="5513829"/>
             <a:ext cx="10424160" cy="685800"/>
           </a:xfrm>
           <a:prstGeom prst="roundRect">

</xml_diff>